<commit_message>
[add] M5Stack Unit C6L の画像を追加
</commit_message>
<xml_diff>
--- a/assets/device_icons.pptx
+++ b/assets/device_icons.pptx
@@ -274,7 +274,7 @@
           <a:p>
             <a:fld id="{30D63992-91CA-41F7-A16C-71C1C327BEB8}" type="datetimeFigureOut">
               <a:rPr kumimoji="1" lang="ja-JP" altLang="en-US" smtClean="0"/>
-              <a:t>2026/6/2</a:t>
+              <a:t>2026/6/11</a:t>
             </a:fld>
             <a:endParaRPr kumimoji="1" lang="ja-JP" altLang="en-US"/>
           </a:p>
@@ -504,7 +504,7 @@
           <a:p>
             <a:fld id="{30D63992-91CA-41F7-A16C-71C1C327BEB8}" type="datetimeFigureOut">
               <a:rPr kumimoji="1" lang="ja-JP" altLang="en-US" smtClean="0"/>
-              <a:t>2026/6/2</a:t>
+              <a:t>2026/6/11</a:t>
             </a:fld>
             <a:endParaRPr kumimoji="1" lang="ja-JP" altLang="en-US"/>
           </a:p>
@@ -744,7 +744,7 @@
           <a:p>
             <a:fld id="{30D63992-91CA-41F7-A16C-71C1C327BEB8}" type="datetimeFigureOut">
               <a:rPr kumimoji="1" lang="ja-JP" altLang="en-US" smtClean="0"/>
-              <a:t>2026/6/2</a:t>
+              <a:t>2026/6/11</a:t>
             </a:fld>
             <a:endParaRPr kumimoji="1" lang="ja-JP" altLang="en-US"/>
           </a:p>
@@ -974,7 +974,7 @@
           <a:p>
             <a:fld id="{30D63992-91CA-41F7-A16C-71C1C327BEB8}" type="datetimeFigureOut">
               <a:rPr kumimoji="1" lang="ja-JP" altLang="en-US" smtClean="0"/>
-              <a:t>2026/6/2</a:t>
+              <a:t>2026/6/11</a:t>
             </a:fld>
             <a:endParaRPr kumimoji="1" lang="ja-JP" altLang="en-US"/>
           </a:p>
@@ -1249,7 +1249,7 @@
           <a:p>
             <a:fld id="{30D63992-91CA-41F7-A16C-71C1C327BEB8}" type="datetimeFigureOut">
               <a:rPr kumimoji="1" lang="ja-JP" altLang="en-US" smtClean="0"/>
-              <a:t>2026/6/2</a:t>
+              <a:t>2026/6/11</a:t>
             </a:fld>
             <a:endParaRPr kumimoji="1" lang="ja-JP" altLang="en-US"/>
           </a:p>
@@ -1578,7 +1578,7 @@
           <a:p>
             <a:fld id="{30D63992-91CA-41F7-A16C-71C1C327BEB8}" type="datetimeFigureOut">
               <a:rPr kumimoji="1" lang="ja-JP" altLang="en-US" smtClean="0"/>
-              <a:t>2026/6/2</a:t>
+              <a:t>2026/6/11</a:t>
             </a:fld>
             <a:endParaRPr kumimoji="1" lang="ja-JP" altLang="en-US"/>
           </a:p>
@@ -2054,7 +2054,7 @@
           <a:p>
             <a:fld id="{30D63992-91CA-41F7-A16C-71C1C327BEB8}" type="datetimeFigureOut">
               <a:rPr kumimoji="1" lang="ja-JP" altLang="en-US" smtClean="0"/>
-              <a:t>2026/6/2</a:t>
+              <a:t>2026/6/11</a:t>
             </a:fld>
             <a:endParaRPr kumimoji="1" lang="ja-JP" altLang="en-US"/>
           </a:p>
@@ -2195,7 +2195,7 @@
           <a:p>
             <a:fld id="{30D63992-91CA-41F7-A16C-71C1C327BEB8}" type="datetimeFigureOut">
               <a:rPr kumimoji="1" lang="ja-JP" altLang="en-US" smtClean="0"/>
-              <a:t>2026/6/2</a:t>
+              <a:t>2026/6/11</a:t>
             </a:fld>
             <a:endParaRPr kumimoji="1" lang="ja-JP" altLang="en-US"/>
           </a:p>
@@ -2308,7 +2308,7 @@
           <a:p>
             <a:fld id="{30D63992-91CA-41F7-A16C-71C1C327BEB8}" type="datetimeFigureOut">
               <a:rPr kumimoji="1" lang="ja-JP" altLang="en-US" smtClean="0"/>
-              <a:t>2026/6/2</a:t>
+              <a:t>2026/6/11</a:t>
             </a:fld>
             <a:endParaRPr kumimoji="1" lang="ja-JP" altLang="en-US"/>
           </a:p>
@@ -2651,7 +2651,7 @@
           <a:p>
             <a:fld id="{30D63992-91CA-41F7-A16C-71C1C327BEB8}" type="datetimeFigureOut">
               <a:rPr kumimoji="1" lang="ja-JP" altLang="en-US" smtClean="0"/>
-              <a:t>2026/6/2</a:t>
+              <a:t>2026/6/11</a:t>
             </a:fld>
             <a:endParaRPr kumimoji="1" lang="ja-JP" altLang="en-US"/>
           </a:p>
@@ -2939,7 +2939,7 @@
           <a:p>
             <a:fld id="{30D63992-91CA-41F7-A16C-71C1C327BEB8}" type="datetimeFigureOut">
               <a:rPr kumimoji="1" lang="ja-JP" altLang="en-US" smtClean="0"/>
-              <a:t>2026/6/2</a:t>
+              <a:t>2026/6/11</a:t>
             </a:fld>
             <a:endParaRPr kumimoji="1" lang="ja-JP" altLang="en-US"/>
           </a:p>
@@ -3212,7 +3212,7 @@
           <a:p>
             <a:fld id="{30D63992-91CA-41F7-A16C-71C1C327BEB8}" type="datetimeFigureOut">
               <a:rPr kumimoji="1" lang="ja-JP" altLang="en-US" smtClean="0"/>
-              <a:t>2026/6/2</a:t>
+              <a:t>2026/6/11</a:t>
             </a:fld>
             <a:endParaRPr kumimoji="1" lang="ja-JP" altLang="en-US"/>
           </a:p>
@@ -14532,6 +14532,1286 @@
           </p:txBody>
         </p:sp>
       </p:grpSp>
+      <p:grpSp>
+        <p:nvGrpSpPr>
+          <p:cNvPr id="148" name="グループ化 147">
+            <a:extLst>
+              <a:ext uri="{FF2B5EF4-FFF2-40B4-BE49-F238E27FC236}">
+                <a16:creationId xmlns:a16="http://schemas.microsoft.com/office/drawing/2014/main" id="{82F8E2B5-A563-1EB6-13DD-52AC1200CF64}"/>
+              </a:ext>
+            </a:extLst>
+          </p:cNvPr>
+          <p:cNvGrpSpPr/>
+          <p:nvPr/>
+        </p:nvGrpSpPr>
+        <p:grpSpPr>
+          <a:xfrm>
+            <a:off x="8291140" y="702748"/>
+            <a:ext cx="2654158" cy="3210760"/>
+            <a:chOff x="8291140" y="702748"/>
+            <a:chExt cx="2654158" cy="3210760"/>
+          </a:xfrm>
+        </p:grpSpPr>
+        <p:sp>
+          <p:nvSpPr>
+            <p:cNvPr id="144" name="四角形: 上の 2 つの角を丸める 143">
+              <a:extLst>
+                <a:ext uri="{FF2B5EF4-FFF2-40B4-BE49-F238E27FC236}">
+                  <a16:creationId xmlns:a16="http://schemas.microsoft.com/office/drawing/2014/main" id="{0FF3A220-F252-646E-8FD8-2C1D52B07132}"/>
+                </a:ext>
+              </a:extLst>
+            </p:cNvPr>
+            <p:cNvSpPr/>
+            <p:nvPr/>
+          </p:nvSpPr>
+          <p:spPr>
+            <a:xfrm>
+              <a:off x="10028467" y="1581220"/>
+              <a:ext cx="136818" cy="198455"/>
+            </a:xfrm>
+            <a:prstGeom prst="round2SameRect">
+              <a:avLst>
+                <a:gd name="adj1" fmla="val 0"/>
+                <a:gd name="adj2" fmla="val 0"/>
+              </a:avLst>
+            </a:prstGeom>
+            <a:solidFill>
+              <a:schemeClr val="accent4">
+                <a:lumMod val="75000"/>
+              </a:schemeClr>
+            </a:solidFill>
+            <a:ln w="28575">
+              <a:noFill/>
+            </a:ln>
+          </p:spPr>
+          <p:style>
+            <a:lnRef idx="2">
+              <a:schemeClr val="accent1">
+                <a:shade val="50000"/>
+              </a:schemeClr>
+            </a:lnRef>
+            <a:fillRef idx="1">
+              <a:schemeClr val="accent1"/>
+            </a:fillRef>
+            <a:effectRef idx="0">
+              <a:schemeClr val="accent1"/>
+            </a:effectRef>
+            <a:fontRef idx="minor">
+              <a:schemeClr val="lt1"/>
+            </a:fontRef>
+          </p:style>
+          <p:txBody>
+            <a:bodyPr rtlCol="0" anchor="ctr"/>
+            <a:lstStyle/>
+            <a:p>
+              <a:pPr algn="ctr"/>
+              <a:endParaRPr kumimoji="1" lang="ja-JP" altLang="en-US"/>
+            </a:p>
+          </p:txBody>
+        </p:sp>
+        <p:sp>
+          <p:nvSpPr>
+            <p:cNvPr id="147" name="四角形: 上の 2 つの角を丸める 146">
+              <a:extLst>
+                <a:ext uri="{FF2B5EF4-FFF2-40B4-BE49-F238E27FC236}">
+                  <a16:creationId xmlns:a16="http://schemas.microsoft.com/office/drawing/2014/main" id="{1CB0DB8C-A712-3359-7F42-F6B2914069FD}"/>
+                </a:ext>
+              </a:extLst>
+            </p:cNvPr>
+            <p:cNvSpPr/>
+            <p:nvPr/>
+          </p:nvSpPr>
+          <p:spPr>
+            <a:xfrm>
+              <a:off x="9495868" y="1581220"/>
+              <a:ext cx="136818" cy="198455"/>
+            </a:xfrm>
+            <a:prstGeom prst="round2SameRect">
+              <a:avLst>
+                <a:gd name="adj1" fmla="val 0"/>
+                <a:gd name="adj2" fmla="val 0"/>
+              </a:avLst>
+            </a:prstGeom>
+            <a:solidFill>
+              <a:schemeClr val="accent4">
+                <a:lumMod val="75000"/>
+              </a:schemeClr>
+            </a:solidFill>
+            <a:ln w="28575">
+              <a:noFill/>
+            </a:ln>
+          </p:spPr>
+          <p:style>
+            <a:lnRef idx="2">
+              <a:schemeClr val="accent1">
+                <a:shade val="50000"/>
+              </a:schemeClr>
+            </a:lnRef>
+            <a:fillRef idx="1">
+              <a:schemeClr val="accent1"/>
+            </a:fillRef>
+            <a:effectRef idx="0">
+              <a:schemeClr val="accent1"/>
+            </a:effectRef>
+            <a:fontRef idx="minor">
+              <a:schemeClr val="lt1"/>
+            </a:fontRef>
+          </p:style>
+          <p:txBody>
+            <a:bodyPr rtlCol="0" anchor="ctr"/>
+            <a:lstStyle/>
+            <a:p>
+              <a:pPr algn="ctr"/>
+              <a:endParaRPr kumimoji="1" lang="ja-JP" altLang="en-US"/>
+            </a:p>
+          </p:txBody>
+        </p:sp>
+        <p:grpSp>
+          <p:nvGrpSpPr>
+            <p:cNvPr id="131" name="グループ化 130">
+              <a:extLst>
+                <a:ext uri="{FF2B5EF4-FFF2-40B4-BE49-F238E27FC236}">
+                  <a16:creationId xmlns:a16="http://schemas.microsoft.com/office/drawing/2014/main" id="{080B16C5-0B96-6DC2-FF2E-9D3540684FB9}"/>
+                </a:ext>
+              </a:extLst>
+            </p:cNvPr>
+            <p:cNvGrpSpPr/>
+            <p:nvPr/>
+          </p:nvGrpSpPr>
+          <p:grpSpPr>
+            <a:xfrm>
+              <a:off x="9328675" y="1777227"/>
+              <a:ext cx="1005752" cy="2136281"/>
+              <a:chOff x="9402644" y="1275473"/>
+              <a:chExt cx="1005752" cy="2136281"/>
+            </a:xfrm>
+          </p:grpSpPr>
+          <p:sp>
+            <p:nvSpPr>
+              <p:cNvPr id="13" name="四角形: 角を丸くする 12">
+                <a:extLst>
+                  <a:ext uri="{FF2B5EF4-FFF2-40B4-BE49-F238E27FC236}">
+                    <a16:creationId xmlns:a16="http://schemas.microsoft.com/office/drawing/2014/main" id="{1A115E63-BE76-CB5E-EC7B-3F0232B2D074}"/>
+                  </a:ext>
+                </a:extLst>
+              </p:cNvPr>
+              <p:cNvSpPr/>
+              <p:nvPr/>
+            </p:nvSpPr>
+            <p:spPr>
+              <a:xfrm>
+                <a:off x="9402644" y="1275473"/>
+                <a:ext cx="1005752" cy="2120615"/>
+              </a:xfrm>
+              <a:prstGeom prst="roundRect">
+                <a:avLst>
+                  <a:gd name="adj" fmla="val 10000"/>
+                </a:avLst>
+              </a:prstGeom>
+              <a:solidFill>
+                <a:schemeClr val="tx1">
+                  <a:lumMod val="65000"/>
+                  <a:lumOff val="35000"/>
+                </a:schemeClr>
+              </a:solidFill>
+              <a:ln w="28575">
+                <a:solidFill>
+                  <a:schemeClr val="tx1">
+                    <a:lumMod val="75000"/>
+                    <a:lumOff val="25000"/>
+                  </a:schemeClr>
+                </a:solidFill>
+              </a:ln>
+            </p:spPr>
+            <p:style>
+              <a:lnRef idx="2">
+                <a:schemeClr val="accent1">
+                  <a:shade val="50000"/>
+                </a:schemeClr>
+              </a:lnRef>
+              <a:fillRef idx="1">
+                <a:schemeClr val="accent1"/>
+              </a:fillRef>
+              <a:effectRef idx="0">
+                <a:schemeClr val="accent1"/>
+              </a:effectRef>
+              <a:fontRef idx="minor">
+                <a:schemeClr val="lt1"/>
+              </a:fontRef>
+            </p:style>
+            <p:txBody>
+              <a:bodyPr rtlCol="0" anchor="ctr"/>
+              <a:lstStyle/>
+              <a:p>
+                <a:pPr algn="ctr"/>
+                <a:endParaRPr kumimoji="1" lang="ja-JP" altLang="en-US"/>
+              </a:p>
+            </p:txBody>
+          </p:sp>
+          <p:sp>
+            <p:nvSpPr>
+              <p:cNvPr id="14" name="正方形/長方形 13">
+                <a:extLst>
+                  <a:ext uri="{FF2B5EF4-FFF2-40B4-BE49-F238E27FC236}">
+                    <a16:creationId xmlns:a16="http://schemas.microsoft.com/office/drawing/2014/main" id="{CFCAEF3A-A4E9-799F-169D-826564F74BB7}"/>
+                  </a:ext>
+                </a:extLst>
+              </p:cNvPr>
+              <p:cNvSpPr/>
+              <p:nvPr/>
+            </p:nvSpPr>
+            <p:spPr>
+              <a:xfrm>
+                <a:off x="9568248" y="1880027"/>
+                <a:ext cx="674544" cy="467712"/>
+              </a:xfrm>
+              <a:prstGeom prst="rect">
+                <a:avLst/>
+              </a:prstGeom>
+              <a:solidFill>
+                <a:schemeClr val="tx1">
+                  <a:lumMod val="95000"/>
+                  <a:lumOff val="5000"/>
+                </a:schemeClr>
+              </a:solidFill>
+              <a:ln>
+                <a:noFill/>
+              </a:ln>
+            </p:spPr>
+            <p:style>
+              <a:lnRef idx="2">
+                <a:schemeClr val="accent1">
+                  <a:shade val="50000"/>
+                </a:schemeClr>
+              </a:lnRef>
+              <a:fillRef idx="1">
+                <a:schemeClr val="accent1"/>
+              </a:fillRef>
+              <a:effectRef idx="0">
+                <a:schemeClr val="accent1"/>
+              </a:effectRef>
+              <a:fontRef idx="minor">
+                <a:schemeClr val="lt1"/>
+              </a:fontRef>
+            </p:style>
+            <p:txBody>
+              <a:bodyPr rtlCol="0" anchor="ctr"/>
+              <a:lstStyle/>
+              <a:p>
+                <a:pPr algn="ctr"/>
+                <a:endParaRPr kumimoji="1" lang="ja-JP" altLang="en-US"/>
+              </a:p>
+            </p:txBody>
+          </p:sp>
+          <p:sp>
+            <p:nvSpPr>
+              <p:cNvPr id="17" name="四角形: 角を丸くする 16">
+                <a:extLst>
+                  <a:ext uri="{FF2B5EF4-FFF2-40B4-BE49-F238E27FC236}">
+                    <a16:creationId xmlns:a16="http://schemas.microsoft.com/office/drawing/2014/main" id="{5DF4D089-5278-9537-3D77-9F5F8EEEEEB8}"/>
+                  </a:ext>
+                </a:extLst>
+              </p:cNvPr>
+              <p:cNvSpPr/>
+              <p:nvPr/>
+            </p:nvSpPr>
+            <p:spPr>
+              <a:xfrm>
+                <a:off x="9596866" y="2425806"/>
+                <a:ext cx="617308" cy="415925"/>
+              </a:xfrm>
+              <a:prstGeom prst="roundRect">
+                <a:avLst/>
+              </a:prstGeom>
+              <a:solidFill>
+                <a:schemeClr val="tx1">
+                  <a:lumMod val="65000"/>
+                  <a:lumOff val="35000"/>
+                </a:schemeClr>
+              </a:solidFill>
+              <a:ln w="19050">
+                <a:solidFill>
+                  <a:schemeClr val="tx1">
+                    <a:lumMod val="95000"/>
+                    <a:lumOff val="5000"/>
+                  </a:schemeClr>
+                </a:solidFill>
+              </a:ln>
+            </p:spPr>
+            <p:style>
+              <a:lnRef idx="2">
+                <a:schemeClr val="accent1">
+                  <a:shade val="50000"/>
+                </a:schemeClr>
+              </a:lnRef>
+              <a:fillRef idx="1">
+                <a:schemeClr val="accent1"/>
+              </a:fillRef>
+              <a:effectRef idx="0">
+                <a:schemeClr val="accent1"/>
+              </a:effectRef>
+              <a:fontRef idx="minor">
+                <a:schemeClr val="lt1"/>
+              </a:fontRef>
+            </p:style>
+            <p:txBody>
+              <a:bodyPr rtlCol="0" anchor="ctr"/>
+              <a:lstStyle/>
+              <a:p>
+                <a:pPr algn="ctr"/>
+                <a:endParaRPr kumimoji="1" lang="ja-JP" altLang="en-US"/>
+              </a:p>
+            </p:txBody>
+          </p:sp>
+          <p:sp>
+            <p:nvSpPr>
+              <p:cNvPr id="25" name="正方形/長方形 24">
+                <a:extLst>
+                  <a:ext uri="{FF2B5EF4-FFF2-40B4-BE49-F238E27FC236}">
+                    <a16:creationId xmlns:a16="http://schemas.microsoft.com/office/drawing/2014/main" id="{30D145F0-CE39-EACB-E7A6-907B0C0ECD50}"/>
+                  </a:ext>
+                </a:extLst>
+              </p:cNvPr>
+              <p:cNvSpPr/>
+              <p:nvPr/>
+            </p:nvSpPr>
+            <p:spPr>
+              <a:xfrm>
+                <a:off x="9520410" y="2770712"/>
+                <a:ext cx="730273" cy="92075"/>
+              </a:xfrm>
+              <a:prstGeom prst="rect">
+                <a:avLst/>
+              </a:prstGeom>
+              <a:solidFill>
+                <a:schemeClr val="tx1">
+                  <a:lumMod val="65000"/>
+                  <a:lumOff val="35000"/>
+                </a:schemeClr>
+              </a:solidFill>
+              <a:ln>
+                <a:noFill/>
+              </a:ln>
+            </p:spPr>
+            <p:style>
+              <a:lnRef idx="2">
+                <a:schemeClr val="accent1">
+                  <a:shade val="50000"/>
+                </a:schemeClr>
+              </a:lnRef>
+              <a:fillRef idx="1">
+                <a:schemeClr val="accent1"/>
+              </a:fillRef>
+              <a:effectRef idx="0">
+                <a:schemeClr val="accent1"/>
+              </a:effectRef>
+              <a:fontRef idx="minor">
+                <a:schemeClr val="lt1"/>
+              </a:fontRef>
+            </p:style>
+            <p:txBody>
+              <a:bodyPr rtlCol="0" anchor="ctr"/>
+              <a:lstStyle/>
+              <a:p>
+                <a:pPr algn="ctr"/>
+                <a:endParaRPr kumimoji="1" lang="ja-JP" altLang="en-US"/>
+              </a:p>
+            </p:txBody>
+          </p:sp>
+          <p:sp>
+            <p:nvSpPr>
+              <p:cNvPr id="39" name="テキスト ボックス 38">
+                <a:extLst>
+                  <a:ext uri="{FF2B5EF4-FFF2-40B4-BE49-F238E27FC236}">
+                    <a16:creationId xmlns:a16="http://schemas.microsoft.com/office/drawing/2014/main" id="{9CF4B86C-BE69-95D9-0165-EA02F734C1B3}"/>
+                  </a:ext>
+                </a:extLst>
+              </p:cNvPr>
+              <p:cNvSpPr txBox="1"/>
+              <p:nvPr/>
+            </p:nvSpPr>
+            <p:spPr>
+              <a:xfrm>
+                <a:off x="9429270" y="1886073"/>
+                <a:ext cx="952500" cy="461665"/>
+              </a:xfrm>
+              <a:prstGeom prst="rect">
+                <a:avLst/>
+              </a:prstGeom>
+              <a:noFill/>
+            </p:spPr>
+            <p:txBody>
+              <a:bodyPr wrap="square" rtlCol="0">
+                <a:spAutoFit/>
+              </a:bodyPr>
+              <a:lstStyle/>
+              <a:p>
+                <a:pPr algn="ctr"/>
+                <a:r>
+                  <a:rPr kumimoji="1" lang="en-US" altLang="ja-JP" sz="1200" b="1">
+                    <a:solidFill>
+                      <a:schemeClr val="bg1"/>
+                    </a:solidFill>
+                    <a:latin typeface="Arial" panose="020B0604020202020204" pitchFamily="34" charset="0"/>
+                    <a:cs typeface="Arial" panose="020B0604020202020204" pitchFamily="34" charset="0"/>
+                  </a:rPr>
+                  <a:t>M5Stack</a:t>
+                </a:r>
+                <a:br>
+                  <a:rPr kumimoji="1" lang="en-US" altLang="ja-JP" sz="1200" b="1">
+                    <a:solidFill>
+                      <a:schemeClr val="bg1"/>
+                    </a:solidFill>
+                    <a:latin typeface="Arial" panose="020B0604020202020204" pitchFamily="34" charset="0"/>
+                    <a:cs typeface="Arial" panose="020B0604020202020204" pitchFamily="34" charset="0"/>
+                  </a:rPr>
+                </a:br>
+                <a:r>
+                  <a:rPr kumimoji="1" lang="en-US" altLang="ja-JP" sz="1200" b="1">
+                    <a:solidFill>
+                      <a:schemeClr val="bg1"/>
+                    </a:solidFill>
+                    <a:latin typeface="Arial" panose="020B0604020202020204" pitchFamily="34" charset="0"/>
+                    <a:cs typeface="Arial" panose="020B0604020202020204" pitchFamily="34" charset="0"/>
+                  </a:rPr>
+                  <a:t>Unit C6L</a:t>
+                </a:r>
+                <a:endParaRPr kumimoji="1" lang="ja-JP" altLang="en-US" sz="1200" b="1" dirty="0">
+                  <a:solidFill>
+                    <a:schemeClr val="bg1"/>
+                  </a:solidFill>
+                  <a:latin typeface="Arial" panose="020B0604020202020204" pitchFamily="34" charset="0"/>
+                  <a:cs typeface="Arial" panose="020B0604020202020204" pitchFamily="34" charset="0"/>
+                </a:endParaRPr>
+              </a:p>
+            </p:txBody>
+          </p:sp>
+          <p:sp>
+            <p:nvSpPr>
+              <p:cNvPr id="40" name="正方形/長方形 39">
+                <a:extLst>
+                  <a:ext uri="{FF2B5EF4-FFF2-40B4-BE49-F238E27FC236}">
+                    <a16:creationId xmlns:a16="http://schemas.microsoft.com/office/drawing/2014/main" id="{BDBEBF26-D485-E01D-85C2-22BDA1E700A6}"/>
+                  </a:ext>
+                </a:extLst>
+              </p:cNvPr>
+              <p:cNvSpPr/>
+              <p:nvPr/>
+            </p:nvSpPr>
+            <p:spPr>
+              <a:xfrm>
+                <a:off x="9490315" y="1337899"/>
+                <a:ext cx="830410" cy="467712"/>
+              </a:xfrm>
+              <a:prstGeom prst="rect">
+                <a:avLst/>
+              </a:prstGeom>
+              <a:solidFill>
+                <a:schemeClr val="bg1"/>
+              </a:solidFill>
+              <a:ln>
+                <a:noFill/>
+              </a:ln>
+            </p:spPr>
+            <p:style>
+              <a:lnRef idx="2">
+                <a:schemeClr val="accent1">
+                  <a:shade val="50000"/>
+                </a:schemeClr>
+              </a:lnRef>
+              <a:fillRef idx="1">
+                <a:schemeClr val="accent1"/>
+              </a:fillRef>
+              <a:effectRef idx="0">
+                <a:schemeClr val="accent1"/>
+              </a:effectRef>
+              <a:fontRef idx="minor">
+                <a:schemeClr val="lt1"/>
+              </a:fontRef>
+            </p:style>
+            <p:txBody>
+              <a:bodyPr rtlCol="0" anchor="ctr"/>
+              <a:lstStyle/>
+              <a:p>
+                <a:pPr algn="ctr"/>
+                <a:endParaRPr kumimoji="1" lang="ja-JP" altLang="en-US"/>
+              </a:p>
+            </p:txBody>
+          </p:sp>
+          <p:sp>
+            <p:nvSpPr>
+              <p:cNvPr id="42" name="正方形/長方形 41">
+                <a:extLst>
+                  <a:ext uri="{FF2B5EF4-FFF2-40B4-BE49-F238E27FC236}">
+                    <a16:creationId xmlns:a16="http://schemas.microsoft.com/office/drawing/2014/main" id="{C908209D-2E7B-94AF-6FCC-0E0A73A779B8}"/>
+                  </a:ext>
+                </a:extLst>
+              </p:cNvPr>
+              <p:cNvSpPr/>
+              <p:nvPr/>
+            </p:nvSpPr>
+            <p:spPr>
+              <a:xfrm>
+                <a:off x="9693430" y="3149993"/>
+                <a:ext cx="424180" cy="261494"/>
+              </a:xfrm>
+              <a:prstGeom prst="rect">
+                <a:avLst/>
+              </a:prstGeom>
+              <a:solidFill>
+                <a:schemeClr val="bg1"/>
+              </a:solidFill>
+              <a:ln>
+                <a:noFill/>
+              </a:ln>
+            </p:spPr>
+            <p:style>
+              <a:lnRef idx="2">
+                <a:schemeClr val="accent1">
+                  <a:shade val="50000"/>
+                </a:schemeClr>
+              </a:lnRef>
+              <a:fillRef idx="1">
+                <a:schemeClr val="accent1"/>
+              </a:fillRef>
+              <a:effectRef idx="0">
+                <a:schemeClr val="accent1"/>
+              </a:effectRef>
+              <a:fontRef idx="minor">
+                <a:schemeClr val="lt1"/>
+              </a:fontRef>
+            </p:style>
+            <p:txBody>
+              <a:bodyPr rtlCol="0" anchor="ctr"/>
+              <a:lstStyle/>
+              <a:p>
+                <a:pPr algn="ctr"/>
+                <a:endParaRPr kumimoji="1" lang="ja-JP" altLang="en-US"/>
+              </a:p>
+            </p:txBody>
+          </p:sp>
+          <p:sp>
+            <p:nvSpPr>
+              <p:cNvPr id="44" name="楕円 43">
+                <a:extLst>
+                  <a:ext uri="{FF2B5EF4-FFF2-40B4-BE49-F238E27FC236}">
+                    <a16:creationId xmlns:a16="http://schemas.microsoft.com/office/drawing/2014/main" id="{6220B3DC-14AE-37C9-B07C-77486E803989}"/>
+                  </a:ext>
+                </a:extLst>
+              </p:cNvPr>
+              <p:cNvSpPr/>
+              <p:nvPr/>
+            </p:nvSpPr>
+            <p:spPr>
+              <a:xfrm>
+                <a:off x="9451754" y="2875989"/>
+                <a:ext cx="190909" cy="190909"/>
+              </a:xfrm>
+              <a:prstGeom prst="ellipse">
+                <a:avLst/>
+              </a:prstGeom>
+              <a:solidFill>
+                <a:schemeClr val="bg1"/>
+              </a:solidFill>
+              <a:ln>
+                <a:noFill/>
+              </a:ln>
+            </p:spPr>
+            <p:style>
+              <a:lnRef idx="2">
+                <a:schemeClr val="accent1">
+                  <a:shade val="50000"/>
+                </a:schemeClr>
+              </a:lnRef>
+              <a:fillRef idx="1">
+                <a:schemeClr val="accent1"/>
+              </a:fillRef>
+              <a:effectRef idx="0">
+                <a:schemeClr val="accent1"/>
+              </a:effectRef>
+              <a:fontRef idx="minor">
+                <a:schemeClr val="lt1"/>
+              </a:fontRef>
+            </p:style>
+            <p:txBody>
+              <a:bodyPr rtlCol="0" anchor="ctr"/>
+              <a:lstStyle/>
+              <a:p>
+                <a:pPr algn="ctr"/>
+                <a:endParaRPr kumimoji="1" lang="ja-JP" altLang="en-US"/>
+              </a:p>
+            </p:txBody>
+          </p:sp>
+          <p:sp>
+            <p:nvSpPr>
+              <p:cNvPr id="47" name="楕円 46">
+                <a:extLst>
+                  <a:ext uri="{FF2B5EF4-FFF2-40B4-BE49-F238E27FC236}">
+                    <a16:creationId xmlns:a16="http://schemas.microsoft.com/office/drawing/2014/main" id="{BBB5683B-8502-6A8B-0E85-B80E9DA9A70B}"/>
+                  </a:ext>
+                </a:extLst>
+              </p:cNvPr>
+              <p:cNvSpPr/>
+              <p:nvPr/>
+            </p:nvSpPr>
+            <p:spPr>
+              <a:xfrm>
+                <a:off x="10155228" y="2871686"/>
+                <a:ext cx="190909" cy="190909"/>
+              </a:xfrm>
+              <a:prstGeom prst="ellipse">
+                <a:avLst/>
+              </a:prstGeom>
+              <a:solidFill>
+                <a:schemeClr val="bg1"/>
+              </a:solidFill>
+              <a:ln>
+                <a:noFill/>
+              </a:ln>
+            </p:spPr>
+            <p:style>
+              <a:lnRef idx="2">
+                <a:schemeClr val="accent1">
+                  <a:shade val="50000"/>
+                </a:schemeClr>
+              </a:lnRef>
+              <a:fillRef idx="1">
+                <a:schemeClr val="accent1"/>
+              </a:fillRef>
+              <a:effectRef idx="0">
+                <a:schemeClr val="accent1"/>
+              </a:effectRef>
+              <a:fontRef idx="minor">
+                <a:schemeClr val="lt1"/>
+              </a:fontRef>
+            </p:style>
+            <p:txBody>
+              <a:bodyPr rtlCol="0" anchor="ctr"/>
+              <a:lstStyle/>
+              <a:p>
+                <a:pPr algn="ctr"/>
+                <a:endParaRPr kumimoji="1" lang="ja-JP" altLang="en-US"/>
+              </a:p>
+            </p:txBody>
+          </p:sp>
+          <p:cxnSp>
+            <p:nvCxnSpPr>
+              <p:cNvPr id="51" name="直線コネクタ 50">
+                <a:extLst>
+                  <a:ext uri="{FF2B5EF4-FFF2-40B4-BE49-F238E27FC236}">
+                    <a16:creationId xmlns:a16="http://schemas.microsoft.com/office/drawing/2014/main" id="{D25514B8-409F-C334-CD3A-966AFF733D79}"/>
+                  </a:ext>
+                </a:extLst>
+              </p:cNvPr>
+              <p:cNvCxnSpPr>
+                <a:cxnSpLocks/>
+              </p:cNvCxnSpPr>
+              <p:nvPr/>
+            </p:nvCxnSpPr>
+            <p:spPr>
+              <a:xfrm>
+                <a:off x="9716925" y="2611506"/>
+                <a:ext cx="377190" cy="0"/>
+              </a:xfrm>
+              <a:prstGeom prst="line">
+                <a:avLst/>
+              </a:prstGeom>
+              <a:ln w="19050">
+                <a:solidFill>
+                  <a:schemeClr val="tx1">
+                    <a:lumMod val="95000"/>
+                    <a:lumOff val="5000"/>
+                  </a:schemeClr>
+                </a:solidFill>
+              </a:ln>
+            </p:spPr>
+            <p:style>
+              <a:lnRef idx="1">
+                <a:schemeClr val="accent1"/>
+              </a:lnRef>
+              <a:fillRef idx="0">
+                <a:schemeClr val="accent1"/>
+              </a:fillRef>
+              <a:effectRef idx="0">
+                <a:schemeClr val="accent1"/>
+              </a:effectRef>
+              <a:fontRef idx="minor">
+                <a:schemeClr val="tx1"/>
+              </a:fontRef>
+            </p:style>
+          </p:cxnSp>
+          <p:sp>
+            <p:nvSpPr>
+              <p:cNvPr id="52" name="正方形/長方形 51">
+                <a:extLst>
+                  <a:ext uri="{FF2B5EF4-FFF2-40B4-BE49-F238E27FC236}">
+                    <a16:creationId xmlns:a16="http://schemas.microsoft.com/office/drawing/2014/main" id="{31B6A852-21F9-A672-8BFD-F35EA0596E6F}"/>
+                  </a:ext>
+                </a:extLst>
+              </p:cNvPr>
+              <p:cNvSpPr/>
+              <p:nvPr/>
+            </p:nvSpPr>
+            <p:spPr>
+              <a:xfrm>
+                <a:off x="9792174" y="3357241"/>
+                <a:ext cx="226692" cy="54513"/>
+              </a:xfrm>
+              <a:prstGeom prst="rect">
+                <a:avLst/>
+              </a:prstGeom>
+              <a:solidFill>
+                <a:schemeClr val="tx1">
+                  <a:lumMod val="65000"/>
+                  <a:lumOff val="35000"/>
+                </a:schemeClr>
+              </a:solidFill>
+              <a:ln w="28575">
+                <a:noFill/>
+              </a:ln>
+            </p:spPr>
+            <p:style>
+              <a:lnRef idx="2">
+                <a:schemeClr val="accent1">
+                  <a:shade val="50000"/>
+                </a:schemeClr>
+              </a:lnRef>
+              <a:fillRef idx="1">
+                <a:schemeClr val="accent1"/>
+              </a:fillRef>
+              <a:effectRef idx="0">
+                <a:schemeClr val="accent1"/>
+              </a:effectRef>
+              <a:fontRef idx="minor">
+                <a:schemeClr val="lt1"/>
+              </a:fontRef>
+            </p:style>
+            <p:txBody>
+              <a:bodyPr rtlCol="0" anchor="ctr"/>
+              <a:lstStyle/>
+              <a:p>
+                <a:pPr algn="ctr"/>
+                <a:endParaRPr kumimoji="1" lang="ja-JP" altLang="en-US"/>
+              </a:p>
+            </p:txBody>
+          </p:sp>
+          <p:sp>
+            <p:nvSpPr>
+              <p:cNvPr id="130" name="四角形: 上の 2 つの角を丸める 129">
+                <a:extLst>
+                  <a:ext uri="{FF2B5EF4-FFF2-40B4-BE49-F238E27FC236}">
+                    <a16:creationId xmlns:a16="http://schemas.microsoft.com/office/drawing/2014/main" id="{EA9D5D92-3537-32F4-2EB7-401202153576}"/>
+                  </a:ext>
+                </a:extLst>
+              </p:cNvPr>
+              <p:cNvSpPr/>
+              <p:nvPr/>
+            </p:nvSpPr>
+            <p:spPr>
+              <a:xfrm>
+                <a:off x="10239253" y="3194155"/>
+                <a:ext cx="51033" cy="217290"/>
+              </a:xfrm>
+              <a:prstGeom prst="round2SameRect">
+                <a:avLst>
+                  <a:gd name="adj1" fmla="val 50000"/>
+                  <a:gd name="adj2" fmla="val 0"/>
+                </a:avLst>
+              </a:prstGeom>
+              <a:solidFill>
+                <a:schemeClr val="bg1">
+                  <a:lumMod val="65000"/>
+                </a:schemeClr>
+              </a:solidFill>
+              <a:ln w="28575">
+                <a:noFill/>
+              </a:ln>
+            </p:spPr>
+            <p:style>
+              <a:lnRef idx="2">
+                <a:schemeClr val="accent1">
+                  <a:shade val="50000"/>
+                </a:schemeClr>
+              </a:lnRef>
+              <a:fillRef idx="1">
+                <a:schemeClr val="accent1"/>
+              </a:fillRef>
+              <a:effectRef idx="0">
+                <a:schemeClr val="accent1"/>
+              </a:effectRef>
+              <a:fontRef idx="minor">
+                <a:schemeClr val="lt1"/>
+              </a:fontRef>
+            </p:style>
+            <p:txBody>
+              <a:bodyPr rtlCol="0" anchor="ctr"/>
+              <a:lstStyle/>
+              <a:p>
+                <a:pPr algn="ctr"/>
+                <a:endParaRPr kumimoji="1" lang="ja-JP" altLang="en-US"/>
+              </a:p>
+            </p:txBody>
+          </p:sp>
+        </p:grpSp>
+        <p:sp>
+          <p:nvSpPr>
+            <p:cNvPr id="132" name="四角形: 上の 2 つの角を丸める 131">
+              <a:extLst>
+                <a:ext uri="{FF2B5EF4-FFF2-40B4-BE49-F238E27FC236}">
+                  <a16:creationId xmlns:a16="http://schemas.microsoft.com/office/drawing/2014/main" id="{5E8CBD20-C34D-C142-297B-ABB1CF0DB3F8}"/>
+                </a:ext>
+              </a:extLst>
+            </p:cNvPr>
+            <p:cNvSpPr/>
+            <p:nvPr/>
+          </p:nvSpPr>
+          <p:spPr>
+            <a:xfrm rot="18000000">
+              <a:off x="8894066" y="99822"/>
+              <a:ext cx="301859" cy="1507712"/>
+            </a:xfrm>
+            <a:prstGeom prst="round2SameRect">
+              <a:avLst>
+                <a:gd name="adj1" fmla="val 50000"/>
+                <a:gd name="adj2" fmla="val 0"/>
+              </a:avLst>
+            </a:prstGeom>
+            <a:solidFill>
+              <a:schemeClr val="tx1">
+                <a:lumMod val="85000"/>
+                <a:lumOff val="15000"/>
+              </a:schemeClr>
+            </a:solidFill>
+            <a:ln w="28575">
+              <a:noFill/>
+            </a:ln>
+          </p:spPr>
+          <p:style>
+            <a:lnRef idx="2">
+              <a:schemeClr val="accent1">
+                <a:shade val="50000"/>
+              </a:schemeClr>
+            </a:lnRef>
+            <a:fillRef idx="1">
+              <a:schemeClr val="accent1"/>
+            </a:fillRef>
+            <a:effectRef idx="0">
+              <a:schemeClr val="accent1"/>
+            </a:effectRef>
+            <a:fontRef idx="minor">
+              <a:schemeClr val="lt1"/>
+            </a:fontRef>
+          </p:style>
+          <p:txBody>
+            <a:bodyPr rtlCol="0" anchor="ctr"/>
+            <a:lstStyle/>
+            <a:p>
+              <a:pPr algn="ctr"/>
+              <a:endParaRPr kumimoji="1" lang="ja-JP" altLang="en-US"/>
+            </a:p>
+          </p:txBody>
+        </p:sp>
+        <p:sp>
+          <p:nvSpPr>
+            <p:cNvPr id="133" name="四角形: 上の 2 つの角を丸める 132">
+              <a:extLst>
+                <a:ext uri="{FF2B5EF4-FFF2-40B4-BE49-F238E27FC236}">
+                  <a16:creationId xmlns:a16="http://schemas.microsoft.com/office/drawing/2014/main" id="{086536D4-5D20-EE79-1D3D-6AE1BDECA26E}"/>
+                </a:ext>
+              </a:extLst>
+            </p:cNvPr>
+            <p:cNvSpPr/>
+            <p:nvPr/>
+          </p:nvSpPr>
+          <p:spPr>
+            <a:xfrm rot="3600000">
+              <a:off x="10278147" y="496054"/>
+              <a:ext cx="301859" cy="1032442"/>
+            </a:xfrm>
+            <a:prstGeom prst="round2SameRect">
+              <a:avLst>
+                <a:gd name="adj1" fmla="val 50000"/>
+                <a:gd name="adj2" fmla="val 0"/>
+              </a:avLst>
+            </a:prstGeom>
+            <a:solidFill>
+              <a:schemeClr val="tx1">
+                <a:lumMod val="85000"/>
+                <a:lumOff val="15000"/>
+              </a:schemeClr>
+            </a:solidFill>
+            <a:ln w="28575">
+              <a:noFill/>
+            </a:ln>
+          </p:spPr>
+          <p:style>
+            <a:lnRef idx="2">
+              <a:schemeClr val="accent1">
+                <a:shade val="50000"/>
+              </a:schemeClr>
+            </a:lnRef>
+            <a:fillRef idx="1">
+              <a:schemeClr val="accent1"/>
+            </a:fillRef>
+            <a:effectRef idx="0">
+              <a:schemeClr val="accent1"/>
+            </a:effectRef>
+            <a:fontRef idx="minor">
+              <a:schemeClr val="lt1"/>
+            </a:fontRef>
+          </p:style>
+          <p:txBody>
+            <a:bodyPr rtlCol="0" anchor="ctr"/>
+            <a:lstStyle/>
+            <a:p>
+              <a:pPr algn="ctr"/>
+              <a:endParaRPr kumimoji="1" lang="ja-JP" altLang="en-US"/>
+            </a:p>
+          </p:txBody>
+        </p:sp>
+        <p:sp>
+          <p:nvSpPr>
+            <p:cNvPr id="134" name="四角形: 上の 2 つの角を丸める 133">
+              <a:extLst>
+                <a:ext uri="{FF2B5EF4-FFF2-40B4-BE49-F238E27FC236}">
+                  <a16:creationId xmlns:a16="http://schemas.microsoft.com/office/drawing/2014/main" id="{9331ECA9-95DC-72F3-20BE-DFBB9864623D}"/>
+                </a:ext>
+              </a:extLst>
+            </p:cNvPr>
+            <p:cNvSpPr/>
+            <p:nvPr/>
+          </p:nvSpPr>
+          <p:spPr>
+            <a:xfrm>
+              <a:off x="9411441" y="1348091"/>
+              <a:ext cx="301859" cy="387141"/>
+            </a:xfrm>
+            <a:prstGeom prst="round2SameRect">
+              <a:avLst>
+                <a:gd name="adj1" fmla="val 0"/>
+                <a:gd name="adj2" fmla="val 0"/>
+              </a:avLst>
+            </a:prstGeom>
+            <a:solidFill>
+              <a:schemeClr val="tx1">
+                <a:lumMod val="85000"/>
+                <a:lumOff val="15000"/>
+              </a:schemeClr>
+            </a:solidFill>
+            <a:ln w="28575">
+              <a:noFill/>
+            </a:ln>
+          </p:spPr>
+          <p:style>
+            <a:lnRef idx="2">
+              <a:schemeClr val="accent1">
+                <a:shade val="50000"/>
+              </a:schemeClr>
+            </a:lnRef>
+            <a:fillRef idx="1">
+              <a:schemeClr val="accent1"/>
+            </a:fillRef>
+            <a:effectRef idx="0">
+              <a:schemeClr val="accent1"/>
+            </a:effectRef>
+            <a:fontRef idx="minor">
+              <a:schemeClr val="lt1"/>
+            </a:fontRef>
+          </p:style>
+          <p:txBody>
+            <a:bodyPr rtlCol="0" anchor="ctr"/>
+            <a:lstStyle/>
+            <a:p>
+              <a:pPr algn="ctr"/>
+              <a:endParaRPr kumimoji="1" lang="ja-JP" altLang="en-US"/>
+            </a:p>
+          </p:txBody>
+        </p:sp>
+        <p:sp>
+          <p:nvSpPr>
+            <p:cNvPr id="138" name="四角形: 上の 2 つの角を丸める 137">
+              <a:extLst>
+                <a:ext uri="{FF2B5EF4-FFF2-40B4-BE49-F238E27FC236}">
+                  <a16:creationId xmlns:a16="http://schemas.microsoft.com/office/drawing/2014/main" id="{C736BA97-D12F-B772-C0A7-E0816EF39652}"/>
+                </a:ext>
+              </a:extLst>
+            </p:cNvPr>
+            <p:cNvSpPr/>
+            <p:nvPr/>
+          </p:nvSpPr>
+          <p:spPr>
+            <a:xfrm>
+              <a:off x="9944897" y="1350087"/>
+              <a:ext cx="303956" cy="380792"/>
+            </a:xfrm>
+            <a:prstGeom prst="round2SameRect">
+              <a:avLst>
+                <a:gd name="adj1" fmla="val 0"/>
+                <a:gd name="adj2" fmla="val 0"/>
+              </a:avLst>
+            </a:prstGeom>
+            <a:solidFill>
+              <a:schemeClr val="tx1">
+                <a:lumMod val="85000"/>
+                <a:lumOff val="15000"/>
+              </a:schemeClr>
+            </a:solidFill>
+            <a:ln w="28575">
+              <a:noFill/>
+            </a:ln>
+          </p:spPr>
+          <p:style>
+            <a:lnRef idx="2">
+              <a:schemeClr val="accent1">
+                <a:shade val="50000"/>
+              </a:schemeClr>
+            </a:lnRef>
+            <a:fillRef idx="1">
+              <a:schemeClr val="accent1"/>
+            </a:fillRef>
+            <a:effectRef idx="0">
+              <a:schemeClr val="accent1"/>
+            </a:effectRef>
+            <a:fontRef idx="minor">
+              <a:schemeClr val="lt1"/>
+            </a:fontRef>
+          </p:style>
+          <p:txBody>
+            <a:bodyPr rtlCol="0" anchor="ctr"/>
+            <a:lstStyle/>
+            <a:p>
+              <a:pPr algn="ctr"/>
+              <a:endParaRPr kumimoji="1" lang="ja-JP" altLang="en-US"/>
+            </a:p>
+          </p:txBody>
+        </p:sp>
+        <p:sp>
+          <p:nvSpPr>
+            <p:cNvPr id="139" name="四角形: 上の 2 つの角を丸める 138">
+              <a:extLst>
+                <a:ext uri="{FF2B5EF4-FFF2-40B4-BE49-F238E27FC236}">
+                  <a16:creationId xmlns:a16="http://schemas.microsoft.com/office/drawing/2014/main" id="{74777B22-0E84-5466-8767-16D8D9DB788C}"/>
+                </a:ext>
+              </a:extLst>
+            </p:cNvPr>
+            <p:cNvSpPr/>
+            <p:nvPr/>
+          </p:nvSpPr>
+          <p:spPr>
+            <a:xfrm>
+              <a:off x="10029592" y="1228189"/>
+              <a:ext cx="150930" cy="243261"/>
+            </a:xfrm>
+            <a:prstGeom prst="round2SameRect">
+              <a:avLst>
+                <a:gd name="adj1" fmla="val 0"/>
+                <a:gd name="adj2" fmla="val 0"/>
+              </a:avLst>
+            </a:prstGeom>
+            <a:solidFill>
+              <a:schemeClr val="tx1">
+                <a:lumMod val="85000"/>
+                <a:lumOff val="15000"/>
+              </a:schemeClr>
+            </a:solidFill>
+            <a:ln w="28575">
+              <a:noFill/>
+            </a:ln>
+          </p:spPr>
+          <p:style>
+            <a:lnRef idx="2">
+              <a:schemeClr val="accent1">
+                <a:shade val="50000"/>
+              </a:schemeClr>
+            </a:lnRef>
+            <a:fillRef idx="1">
+              <a:schemeClr val="accent1"/>
+            </a:fillRef>
+            <a:effectRef idx="0">
+              <a:schemeClr val="accent1"/>
+            </a:effectRef>
+            <a:fontRef idx="minor">
+              <a:schemeClr val="lt1"/>
+            </a:fontRef>
+          </p:style>
+          <p:txBody>
+            <a:bodyPr rtlCol="0" anchor="ctr"/>
+            <a:lstStyle/>
+            <a:p>
+              <a:pPr algn="ctr"/>
+              <a:endParaRPr kumimoji="1" lang="ja-JP" altLang="en-US"/>
+            </a:p>
+          </p:txBody>
+        </p:sp>
+        <p:sp>
+          <p:nvSpPr>
+            <p:cNvPr id="140" name="四角形: 上の 2 つの角を丸める 139">
+              <a:extLst>
+                <a:ext uri="{FF2B5EF4-FFF2-40B4-BE49-F238E27FC236}">
+                  <a16:creationId xmlns:a16="http://schemas.microsoft.com/office/drawing/2014/main" id="{293CE68E-8674-9210-6034-4A3B12BB4901}"/>
+                </a:ext>
+              </a:extLst>
+            </p:cNvPr>
+            <p:cNvSpPr/>
+            <p:nvPr/>
+          </p:nvSpPr>
+          <p:spPr>
+            <a:xfrm>
+              <a:off x="9489157" y="1226193"/>
+              <a:ext cx="150930" cy="243261"/>
+            </a:xfrm>
+            <a:prstGeom prst="round2SameRect">
+              <a:avLst>
+                <a:gd name="adj1" fmla="val 0"/>
+                <a:gd name="adj2" fmla="val 0"/>
+              </a:avLst>
+            </a:prstGeom>
+            <a:solidFill>
+              <a:schemeClr val="tx1">
+                <a:lumMod val="85000"/>
+                <a:lumOff val="15000"/>
+              </a:schemeClr>
+            </a:solidFill>
+            <a:ln w="28575">
+              <a:noFill/>
+            </a:ln>
+          </p:spPr>
+          <p:style>
+            <a:lnRef idx="2">
+              <a:schemeClr val="accent1">
+                <a:shade val="50000"/>
+              </a:schemeClr>
+            </a:lnRef>
+            <a:fillRef idx="1">
+              <a:schemeClr val="accent1"/>
+            </a:fillRef>
+            <a:effectRef idx="0">
+              <a:schemeClr val="accent1"/>
+            </a:effectRef>
+            <a:fontRef idx="minor">
+              <a:schemeClr val="lt1"/>
+            </a:fontRef>
+          </p:style>
+          <p:txBody>
+            <a:bodyPr rtlCol="0" anchor="ctr"/>
+            <a:lstStyle/>
+            <a:p>
+              <a:pPr algn="ctr"/>
+              <a:endParaRPr kumimoji="1" lang="ja-JP" altLang="en-US"/>
+            </a:p>
+          </p:txBody>
+        </p:sp>
+        <p:sp>
+          <p:nvSpPr>
+            <p:cNvPr id="142" name="四角形: 上の 2 つの角を丸める 141">
+              <a:extLst>
+                <a:ext uri="{FF2B5EF4-FFF2-40B4-BE49-F238E27FC236}">
+                  <a16:creationId xmlns:a16="http://schemas.microsoft.com/office/drawing/2014/main" id="{B334B40C-A73B-B8A8-E778-369C77D0CE2C}"/>
+                </a:ext>
+              </a:extLst>
+            </p:cNvPr>
+            <p:cNvSpPr/>
+            <p:nvPr/>
+          </p:nvSpPr>
+          <p:spPr>
+            <a:xfrm>
+              <a:off x="9945946" y="1348090"/>
+              <a:ext cx="301859" cy="198455"/>
+            </a:xfrm>
+            <a:prstGeom prst="round2SameRect">
+              <a:avLst>
+                <a:gd name="adj1" fmla="val 0"/>
+                <a:gd name="adj2" fmla="val 0"/>
+              </a:avLst>
+            </a:prstGeom>
+            <a:solidFill>
+              <a:srgbClr val="D42A73"/>
+            </a:solidFill>
+            <a:ln w="28575">
+              <a:noFill/>
+            </a:ln>
+          </p:spPr>
+          <p:style>
+            <a:lnRef idx="2">
+              <a:schemeClr val="accent1">
+                <a:shade val="50000"/>
+              </a:schemeClr>
+            </a:lnRef>
+            <a:fillRef idx="1">
+              <a:schemeClr val="accent1"/>
+            </a:fillRef>
+            <a:effectRef idx="0">
+              <a:schemeClr val="accent1"/>
+            </a:effectRef>
+            <a:fontRef idx="minor">
+              <a:schemeClr val="lt1"/>
+            </a:fontRef>
+          </p:style>
+          <p:txBody>
+            <a:bodyPr rtlCol="0" anchor="ctr"/>
+            <a:lstStyle/>
+            <a:p>
+              <a:pPr algn="ctr"/>
+              <a:endParaRPr kumimoji="1" lang="ja-JP" altLang="en-US"/>
+            </a:p>
+          </p:txBody>
+        </p:sp>
+        <p:sp>
+          <p:nvSpPr>
+            <p:cNvPr id="143" name="四角形: 上の 2 つの角を丸める 142">
+              <a:extLst>
+                <a:ext uri="{FF2B5EF4-FFF2-40B4-BE49-F238E27FC236}">
+                  <a16:creationId xmlns:a16="http://schemas.microsoft.com/office/drawing/2014/main" id="{C2025E85-7830-67E2-D52E-12E6957B10C8}"/>
+                </a:ext>
+              </a:extLst>
+            </p:cNvPr>
+            <p:cNvSpPr/>
+            <p:nvPr/>
+          </p:nvSpPr>
+          <p:spPr>
+            <a:xfrm>
+              <a:off x="9411441" y="1348090"/>
+              <a:ext cx="301859" cy="198455"/>
+            </a:xfrm>
+            <a:prstGeom prst="round2SameRect">
+              <a:avLst>
+                <a:gd name="adj1" fmla="val 0"/>
+                <a:gd name="adj2" fmla="val 0"/>
+              </a:avLst>
+            </a:prstGeom>
+            <a:solidFill>
+              <a:srgbClr val="009FFF"/>
+            </a:solidFill>
+            <a:ln w="28575">
+              <a:noFill/>
+            </a:ln>
+          </p:spPr>
+          <p:style>
+            <a:lnRef idx="2">
+              <a:schemeClr val="accent1">
+                <a:shade val="50000"/>
+              </a:schemeClr>
+            </a:lnRef>
+            <a:fillRef idx="1">
+              <a:schemeClr val="accent1"/>
+            </a:fillRef>
+            <a:effectRef idx="0">
+              <a:schemeClr val="accent1"/>
+            </a:effectRef>
+            <a:fontRef idx="minor">
+              <a:schemeClr val="lt1"/>
+            </a:fontRef>
+          </p:style>
+          <p:txBody>
+            <a:bodyPr rtlCol="0" anchor="ctr"/>
+            <a:lstStyle/>
+            <a:p>
+              <a:pPr algn="ctr"/>
+              <a:endParaRPr kumimoji="1" lang="ja-JP" altLang="en-US"/>
+            </a:p>
+          </p:txBody>
+        </p:sp>
+      </p:grpSp>
     </p:spTree>
     <p:extLst>
       <p:ext uri="{BB962C8B-B14F-4D97-AF65-F5344CB8AC3E}">

</xml_diff>